<commit_message>
Update proof index docs and outputs
</commit_message>
<xml_diff>
--- a/output/proofofwork-general-deck.pptx
+++ b/output/proofofwork-general-deck.pptx
@@ -111,7 +111,7 @@
                   <a:srgbClr val="111827"/>
                 </a:solidFill>
               </a:rPr>
-              <a:t>The Bitcoin Computer</a:t>
+              <a:t>The ProofOfWork Computer</a:t>
             </a:r>
           </a:p>
         </p:txBody>
@@ -157,7 +157,7 @@
                   <a:srgbClr val="1f2937"/>
                 </a:solidFill>
               </a:rPr>
-              <a:t>The Bitcoin Computer.</a:t>
+              <a:t>The ProofOfWork Computer.</a:t>
             </a:r>
           </a:p>
           <a:p>
@@ -168,7 +168,7 @@
                   <a:srgbClr val="1f2937"/>
                 </a:solidFill>
               </a:rPr>
-              <a:t>Identity, mail, files, pages, marketplace actions, Pay2Speak funding, token mints, logs, and growth signals written to Bitcoin.</a:t>
+              <a:t>Identity, mail, files, pages, marketplace actions, Pay2Speak funding, token mints, logs, and growth signals written to ProofOfWork.</a:t>
             </a:r>
           </a:p>
         </p:txBody>
@@ -203,7 +203,7 @@
                   <a:srgbClr val="64748b"/>
                 </a:solidFill>
               </a:rPr>
-              <a:t>Bitcoin Computer · local-first · on-chain · agent-readable</a:t>
+              <a:t>ProofOfWork Computer · local-first · on-chain · agent-readable</a:t>
             </a:r>
           </a:p>
         </p:txBody>
@@ -341,7 +341,7 @@
                   <a:srgbClr val="1f2937"/>
                 </a:solidFill>
               </a:rPr>
-              <a:t>Tokens are mint-first and Bitcoin-readable.</a:t>
+              <a:t>Tokens are mint-first and ProofOfWork-readable.</a:t>
             </a:r>
           </a:p>
           <a:p>
@@ -396,18 +396,18 @@
                   <a:srgbClr val="1f2937"/>
                 </a:solidFill>
               </a:rPr>
-              <a:t>WORK starts with 21,000,000 max supply, 1,000 WORK per mint, and 1,000 sats per mint.</a:t>
-            </a:r>
-          </a:p>
-          <a:p>
-            <a:pPr/>
-            <a:r>
-              <a:rPr lang="en-US" sz="2050">
-                <a:solidFill>
-                  <a:srgbClr val="1f2937"/>
-                </a:solidFill>
-              </a:rPr>
-              <a:t>That is exactly 1 sat per WORK.</a:t>
+              <a:t>WORK starts with 21,000,000 max supply, 1,000 WORK per mint, and 1,000 proofs per mint.</a:t>
+            </a:r>
+          </a:p>
+          <a:p>
+            <a:pPr/>
+            <a:r>
+              <a:rPr lang="en-US" sz="2050">
+                <a:solidFill>
+                  <a:srgbClr val="1f2937"/>
+                </a:solidFill>
+              </a:rPr>
+              <a:t>That is exactly 1 proof per WORK.</a:t>
             </a:r>
           </a:p>
         </p:txBody>
@@ -442,7 +442,7 @@
                   <a:srgbClr val="64748b"/>
                 </a:solidFill>
               </a:rPr>
-              <a:t>Bitcoin Computer · local-first · on-chain · agent-readable</a:t>
+              <a:t>ProofOfWork Computer · local-first · on-chain · agent-readable</a:t>
             </a:r>
           </a:p>
         </p:txBody>
@@ -580,7 +580,7 @@
                   <a:srgbClr val="1f2937"/>
                 </a:solidFill>
               </a:rPr>
-              <a:t>Log is the public Bitcoin Computer activity feed.</a:t>
+              <a:t>Log is the public ProofOfWork Computer activity feed.</a:t>
             </a:r>
           </a:p>
           <a:p>
@@ -602,7 +602,7 @@
                   <a:srgbClr val="1f2937"/>
                 </a:solidFill>
               </a:rPr>
-              <a:t>Growth compares the canonical success-case model against real confirmed network value in sats and USD.</a:t>
+              <a:t>Growth compares the canonical success-case model against real confirmed network value in proofs and USD.</a:t>
             </a:r>
           </a:p>
           <a:p>
@@ -703,7 +703,7 @@
                   <a:srgbClr val="64748b"/>
                 </a:solidFill>
               </a:rPr>
-              <a:t>Bitcoin Computer · local-first · on-chain · agent-readable</a:t>
+              <a:t>ProofOfWork Computer · local-first · on-chain · agent-readable</a:t>
             </a:r>
           </a:p>
         </p:txBody>
@@ -885,7 +885,7 @@
                   <a:srgbClr val="374151"/>
                 </a:solidFill>
               </a:rPr>
-              <a:t>Sats with every interaction.</a:t>
+              <a:t>Proofs with every interaction.</a:t>
             </a:r>
           </a:p>
           <a:p>
@@ -964,7 +964,7 @@
                   <a:srgbClr val="64748b"/>
                 </a:solidFill>
               </a:rPr>
-              <a:t>Bitcoin Computer · local-first · on-chain · agent-readable</a:t>
+              <a:t>ProofOfWork Computer · local-first · on-chain · agent-readable</a:t>
             </a:r>
           </a:p>
         </p:txBody>
@@ -1102,7 +1102,7 @@
                   <a:srgbClr val="1f2937"/>
                 </a:solidFill>
               </a:rPr>
-              <a:t>ProofOfWork.Me is a new interface for Bitcoin.</a:t>
+              <a:t>ProofOfWork.Me is a new interface for ProofOfWork.</a:t>
             </a:r>
           </a:p>
           <a:p>
@@ -1269,7 +1269,7 @@
                   <a:srgbClr val="64748b"/>
                 </a:solidFill>
               </a:rPr>
-              <a:t>Bitcoin Computer · local-first · on-chain · agent-readable</a:t>
+              <a:t>ProofOfWork Computer · local-first · on-chain · agent-readable</a:t>
             </a:r>
           </a:p>
         </p:txBody>
@@ -1464,7 +1464,7 @@
                   <a:srgbClr val="64748b"/>
                 </a:solidFill>
               </a:rPr>
-              <a:t>Bitcoin Computer · local-first · on-chain · agent-readable</a:t>
+              <a:t>ProofOfWork Computer · local-first · on-chain · agent-readable</a:t>
             </a:r>
           </a:p>
         </p:txBody>
@@ -1567,7 +1567,7 @@
                   <a:srgbClr val="111827"/>
                 </a:solidFill>
               </a:rPr>
-              <a:t>Bitcoin Is The Source Of Truth</a:t>
+              <a:t>ProofOfWork Is The Source Of Truth</a:t>
             </a:r>
           </a:p>
         </p:txBody>
@@ -1602,7 +1602,7 @@
                   <a:srgbClr val="1f2937"/>
                 </a:solidFill>
               </a:rPr>
-              <a:t>Bitcoin gives the app a hard foundation:</a:t>
+              <a:t>ProofOfWork gives the app a hard foundation:</a:t>
             </a:r>
           </a:p>
           <a:p>
@@ -1714,7 +1714,7 @@
                   <a:srgbClr val="64748b"/>
                 </a:solidFill>
               </a:rPr>
-              <a:t>Bitcoin Computer · local-first · on-chain · agent-readable</a:t>
+              <a:t>ProofOfWork Computer · local-first · on-chain · agent-readable</a:t>
             </a:r>
           </a:p>
         </p:txBody>
@@ -1852,7 +1852,7 @@
                   <a:srgbClr val="1f2937"/>
                 </a:solidFill>
               </a:rPr>
-              <a:t>Claim a permanent Bitcoin-native identity:</a:t>
+              <a:t>Claim a permanent ProofOfWork-native identity:</a:t>
             </a:r>
           </a:p>
           <a:p>
@@ -1874,7 +1874,7 @@
                   <a:srgbClr val="1f2937"/>
                 </a:solidFill>
               </a:rPr>
-              <a:t>IDs resolve to Bitcoin receive addresses.</a:t>
+              <a:t>IDs resolve to ProofOfWork receive addresses.</a:t>
             </a:r>
           </a:p>
           <a:p>
@@ -1931,7 +1931,7 @@
                   <a:srgbClr val="64748b"/>
                 </a:solidFill>
               </a:rPr>
-              <a:t>Bitcoin Computer · local-first · on-chain · agent-readable</a:t>
+              <a:t>ProofOfWork Computer · local-first · on-chain · agent-readable</a:t>
             </a:r>
           </a:p>
         </p:txBody>
@@ -2034,7 +2034,7 @@
                   <a:srgbClr val="111827"/>
                 </a:solidFill>
               </a:rPr>
-              <a:t>Bitcoin Mail</a:t>
+              <a:t>ProofOfWork Mail</a:t>
             </a:r>
           </a:p>
         </p:txBody>
@@ -2069,7 +2069,7 @@
                   <a:srgbClr val="1f2937"/>
                 </a:solidFill>
               </a:rPr>
-              <a:t>Send messages with sats attached.</a:t>
+              <a:t>Send messages with proofs attached.</a:t>
             </a:r>
           </a:p>
           <a:p>
@@ -2137,7 +2137,7 @@
                   <a:srgbClr val="64748b"/>
                 </a:solidFill>
               </a:rPr>
-              <a:t>Bitcoin Computer · local-first · on-chain · agent-readable</a:t>
+              <a:t>ProofOfWork Computer · local-first · on-chain · agent-readable</a:t>
             </a:r>
           </a:p>
         </p:txBody>
@@ -2354,7 +2354,7 @@
                   <a:srgbClr val="64748b"/>
                 </a:solidFill>
               </a:rPr>
-              <a:t>Bitcoin Computer · local-first · on-chain · agent-readable</a:t>
+              <a:t>ProofOfWork Computer · local-first · on-chain · agent-readable</a:t>
             </a:r>
           </a:p>
         </p:txBody>
@@ -2492,7 +2492,7 @@
                   <a:srgbClr val="1f2937"/>
                 </a:solidFill>
               </a:rPr>
-              <a:t>Browser renders HTML from Bitcoin transactions.</a:t>
+              <a:t>Browser renders HTML from ProofOfWork transactions.</a:t>
             </a:r>
           </a:p>
           <a:p>
@@ -2571,7 +2571,7 @@
                   <a:srgbClr val="64748b"/>
                 </a:solidFill>
               </a:rPr>
-              <a:t>Bitcoin Computer · local-first · on-chain · agent-readable</a:t>
+              <a:t>ProofOfWork Computer · local-first · on-chain · agent-readable</a:t>
             </a:r>
           </a:p>
         </p:txBody>
@@ -2709,7 +2709,7 @@
                   <a:srgbClr val="1f2937"/>
                 </a:solidFill>
               </a:rPr>
-              <a:t>The canonical welcome page is already on Bitcoin:</a:t>
+              <a:t>The canonical welcome page is already on ProofOfWork:</a:t>
             </a:r>
           </a:p>
           <a:p>
@@ -2777,7 +2777,7 @@
                   <a:srgbClr val="64748b"/>
                 </a:solidFill>
               </a:rPr>
-              <a:t>Bitcoin Computer · local-first · on-chain · agent-readable</a:t>
+              <a:t>ProofOfWork Computer · local-first · on-chain · agent-readable</a:t>
             </a:r>
           </a:p>
         </p:txBody>
@@ -3003,7 +3003,7 @@
                   <a:srgbClr val="1f2937"/>
                 </a:solidFill>
               </a:rPr>
-              <a:t>Competing buys conflict at the Bitcoin UTXO layer.</a:t>
+              <a:t>Competing buys conflict at the ProofOfWork UTXO layer.</a:t>
             </a:r>
           </a:p>
         </p:txBody>
@@ -3038,7 +3038,7 @@
                   <a:srgbClr val="64748b"/>
                 </a:solidFill>
               </a:rPr>
-              <a:t>Bitcoin Computer · local-first · on-chain · agent-readable</a:t>
+              <a:t>ProofOfWork Computer · local-first · on-chain · agent-readable</a:t>
             </a:r>
           </a:p>
         </p:txBody>

</xml_diff>

<commit_message>
Rename generated model to ProofOfWork
</commit_message>
<xml_diff>
--- a/output/proofofwork-general-deck.pptx
+++ b/output/proofofwork-general-deck.pptx
@@ -168,7 +168,7 @@
                   <a:srgbClr val="1f2937"/>
                 </a:solidFill>
               </a:rPr>
-              <a:t>Identity, mail, files, pages, marketplace actions, Pay2Speak funding, token mints, logs, and growth signals written to ProofOfWork.</a:t>
+              <a:t>Identity, mail, files, pages, marketplace actions, credit mints, wallet transfers, logs, and growth signals written to ProofOfWork.</a:t>
             </a:r>
           </a:p>
         </p:txBody>
@@ -306,7 +306,7 @@
                   <a:srgbClr val="111827"/>
                 </a:solidFill>
               </a:rPr>
-              <a:t>Tokens</a:t>
+              <a:t>Credits</a:t>
             </a:r>
           </a:p>
         </p:txBody>
@@ -341,7 +341,7 @@
                   <a:srgbClr val="1f2937"/>
                 </a:solidFill>
               </a:rPr>
-              <a:t>Tokens are mint-first and ProofOfWork-readable.</a:t>
+              <a:t>Credits are mint-first and ProofOfWork-readable.</a:t>
             </a:r>
           </a:p>
           <a:p>
@@ -374,18 +374,7 @@
                   <a:srgbClr val="1f2937"/>
                 </a:solidFill>
               </a:rPr>
-              <a:t>Creation pays the token index.</a:t>
-            </a:r>
-          </a:p>
-          <a:p>
-            <a:pPr/>
-            <a:r>
-              <a:rPr lang="en-US" sz="2050">
-                <a:solidFill>
-                  <a:srgbClr val="1f2937"/>
-                </a:solidFill>
-              </a:rPr>
-              <a:t>Mints pay each token registry directly at the owner-set price.</a:t>
+              <a:t>Creation pays the credit index.</a:t>
             </a:r>
           </a:p>
           <a:p>
@@ -396,6 +385,17 @@
                   <a:srgbClr val="1f2937"/>
                 </a:solidFill>
               </a:rPr>
+              <a:t>Mints, transfers, listings, seals, delistings, and buys pay each credit registry directly.</a:t>
+            </a:r>
+          </a:p>
+          <a:p>
+            <a:pPr/>
+            <a:r>
+              <a:rPr lang="en-US" sz="1850">
+                <a:solidFill>
+                  <a:srgbClr val="1f2937"/>
+                </a:solidFill>
+              </a:rPr>
               <a:t>WORK starts with 21,000,000 max supply, 1,000 WORK per mint, and 1,000 proofs per mint.</a:t>
             </a:r>
           </a:p>
@@ -408,6 +408,17 @@
                 </a:solidFill>
               </a:rPr>
               <a:t>That is exactly 1 proof per WORK.</a:t>
+            </a:r>
+          </a:p>
+          <a:p>
+            <a:pPr/>
+            <a:r>
+              <a:rPr lang="en-US" sz="1700">
+                <a:solidFill>
+                  <a:srgbClr val="1f2937"/>
+                </a:solidFill>
+              </a:rPr>
+              <a:t>Wallet is the connected-address credit surface for balances, transfer logs, credit transfers, owned listings, delistings, and sale history.</a:t>
             </a:r>
           </a:p>
         </p:txBody>
@@ -591,7 +602,7 @@
                   <a:srgbClr val="1f2937"/>
                 </a:solidFill>
               </a:rPr>
-              <a:t>It indexes registrations, receiver updates, transfers, listings, purchases, messages, replies, files, attachments, Browser-readable pages, Pay2Speak funding, token creations, and token mints.</a:t>
+              <a:t>It indexes registrations, receiver updates, transfers, listings, seals, delistings, purchases, messages, replies, files, attachments, Browser-readable pages, credit creations, credit mints, credit transfers, credit listings, and credit sales.</a:t>
             </a:r>
           </a:p>
           <a:p>
@@ -603,6 +614,17 @@
                 </a:solidFill>
               </a:rPr>
               <a:t>Growth compares the canonical success-case model against real confirmed network value in proofs and USD.</a:t>
+            </a:r>
+          </a:p>
+          <a:p>
+            <a:pPr/>
+            <a:r>
+              <a:rPr lang="en-US" sz="1700">
+                <a:solidFill>
+                  <a:srgbClr val="1f2937"/>
+                </a:solidFill>
+              </a:rPr>
+              <a:t>WORK and Growth share the same confirmed network-value payload and live node-backed BTC/USD benchmark.</a:t>
             </a:r>
           </a:p>
           <a:p>
@@ -907,7 +929,7 @@
                   <a:srgbClr val="374151"/>
                 </a:solidFill>
               </a:rPr>
-              <a:t>Public ownership, marketplace, funding, and token records.</a:t>
+              <a:t>Public ownership, marketplace, funding, and credit records.</a:t>
             </a:r>
           </a:p>
           <a:p>
@@ -1179,18 +1201,7 @@
                   <a:srgbClr val="1f2937"/>
                 </a:solidFill>
               </a:rPr>
-              <a:t>Pay2Speak.</a:t>
-            </a:r>
-          </a:p>
-          <a:p>
-            <a:pPr/>
-            <a:r>
-              <a:rPr lang="en-US" sz="2050">
-                <a:solidFill>
-                  <a:srgbClr val="1f2937"/>
-                </a:solidFill>
-              </a:rPr>
-              <a:t>Tokens.</a:t>
+              <a:t>Credits.</a:t>
             </a:r>
           </a:p>
           <a:p>
@@ -1235,6 +1246,17 @@
                 </a:solidFill>
               </a:rPr>
               <a:t>Agents.</a:t>
+            </a:r>
+          </a:p>
+          <a:p>
+            <a:pPr/>
+            <a:r>
+              <a:rPr lang="en-US" sz="2050">
+                <a:solidFill>
+                  <a:srgbClr val="1f2937"/>
+                </a:solidFill>
+              </a:rPr>
+              <a:t>Value.</a:t>
             </a:r>
           </a:p>
         </p:txBody>
@@ -2926,7 +2948,18 @@
                   <a:srgbClr val="1f2937"/>
                 </a:solidFill>
               </a:rPr>
-              <a:t>Current marketplace protocol:</a:t>
+              <a:t>Credits are transferable market assets too.</a:t>
+            </a:r>
+          </a:p>
+          <a:p>
+            <a:pPr/>
+            <a:r>
+              <a:rPr lang="en-US" sz="2050">
+                <a:solidFill>
+                  <a:srgbClr val="1f2937"/>
+                </a:solidFill>
+              </a:rPr>
+              <a:t>Current marketplace protocols:</a:t>
             </a:r>
           </a:p>
           <a:p>
@@ -2981,7 +3014,51 @@
                   <a:srgbClr val="1f2937"/>
                 </a:solidFill>
               </a:rPr>
-              <a:t>Sellers publish on-chain listings.</a:t>
+              <a:t>pwt1:list5</a:t>
+            </a:r>
+          </a:p>
+          <a:p>
+            <a:pPr/>
+            <a:r>
+              <a:rPr lang="en-US" sz="2050">
+                <a:solidFill>
+                  <a:srgbClr val="1f2937"/>
+                </a:solidFill>
+              </a:rPr>
+              <a:t>pwt1:seal5</a:t>
+            </a:r>
+          </a:p>
+          <a:p>
+            <a:pPr/>
+            <a:r>
+              <a:rPr lang="en-US" sz="2050">
+                <a:solidFill>
+                  <a:srgbClr val="1f2937"/>
+                </a:solidFill>
+              </a:rPr>
+              <a:t>pwt1:buy5</a:t>
+            </a:r>
+          </a:p>
+          <a:p>
+            <a:pPr/>
+            <a:r>
+              <a:rPr lang="en-US" sz="2050">
+                <a:solidFill>
+                  <a:srgbClr val="1f2937"/>
+                </a:solidFill>
+              </a:rPr>
+              <a:t>pwt1:delist5</a:t>
+            </a:r>
+          </a:p>
+          <a:p>
+            <a:pPr/>
+            <a:r>
+              <a:rPr lang="en-US" sz="2050">
+                <a:solidFill>
+                  <a:srgbClr val="1f2937"/>
+                </a:solidFill>
+              </a:rPr>
+              <a:t>Sellers publish on-chain listings and seal exact sale terms.</a:t>
             </a:r>
           </a:p>
           <a:p>
@@ -2992,18 +3069,7 @@
                   <a:srgbClr val="1f2937"/>
                 </a:solidFill>
               </a:rPr>
-              <a:t>Buyers settle by spending a sale-ticket UTXO, paying the seller, paying the registry mutation fee, and writing the transfer event.</a:t>
-            </a:r>
-          </a:p>
-          <a:p>
-            <a:pPr/>
-            <a:r>
-              <a:rPr lang="en-US" sz="2050">
-                <a:solidFill>
-                  <a:srgbClr val="1f2937"/>
-                </a:solidFill>
-              </a:rPr>
-              <a:t>Competing buys conflict at the ProofOfWork UTXO layer.</a:t>
+              <a:t>Buyers settle by spending a sale-ticket UTXO, paying the seller, paying the registry mutation fee, and writing the transfer or buy event.</a:t>
             </a:r>
           </a:p>
         </p:txBody>

</xml_diff>

<commit_message>
Implement WORK AMO V5 unit protocol
Documentation-Impact: updated
Repository-Hygiene: reviewed
</commit_message>
<xml_diff>
--- a/output/proofofwork-general-deck.pptx
+++ b/output/proofofwork-general-deck.pptx
@@ -169,7 +169,7 @@
                   <a:srgbClr val="1f2937"/>
                 </a:solidFill>
               </a:rPr>
-              <a:t>Identity, mail, files, pages, marketplace actions, credit mints, wallet transfers, bonds, logs, and growth signals written to ProofOfWork.</a:t>
+              <a:t>Identity, mail, files, pages, AMO actions, credit mints, wallet transfers, bonds, logs, and growth signals written to ProofOfWork.</a:t>
             </a:r>
           </a:p>
         </p:txBody>
@@ -1169,7 +1169,7 @@
                   <a:srgbClr val="374151"/>
                 </a:solidFill>
               </a:rPr>
-              <a:t>Public ownership, marketplace, funding, and credit records.</a:t>
+              <a:t>Public ownership, AMO, funding, and credit records.</a:t>
             </a:r>
           </a:p>
           <a:p>
@@ -1386,7 +1386,7 @@
                   <a:srgbClr val="1f2937"/>
                 </a:solidFill>
               </a:rPr>
-              <a:t>Marketplace. Credits. Wallet. WORK.</a:t>
+              <a:t>AMO. Credits. Wallet. WORK.</a:t>
             </a:r>
           </a:p>
           <a:p>
@@ -2087,12 +2087,12 @@
           <a:p>
             <a:pPr/>
             <a:r>
-              <a:rPr lang="en-US" sz="1850">
-                <a:solidFill>
-                  <a:srgbClr val="1f2937"/>
-                </a:solidFill>
-              </a:rPr>
-              <a:t>Owners can update receivers, transfer IDs, and list IDs in the marketplace.</a:t>
+              <a:rPr lang="en-US" sz="2050">
+                <a:solidFill>
+                  <a:srgbClr val="1f2937"/>
+                </a:solidFill>
+              </a:rPr>
+              <a:t>Owners can update receivers, transfer IDs, and list IDs in AMO.</a:t>
             </a:r>
           </a:p>
         </p:txBody>
@@ -3076,7 +3076,7 @@
                   <a:srgbClr val="111827"/>
                 </a:solidFill>
               </a:rPr>
-              <a:t>Marketplace</a:t>
+              <a:t>AMO</a:t>
             </a:r>
           </a:p>
         </p:txBody>
@@ -3106,23 +3106,23 @@
           <a:p>
             <a:pPr/>
             <a:r>
-              <a:rPr lang="en-US" sz="2050">
-                <a:solidFill>
-                  <a:srgbClr val="1f2937"/>
-                </a:solidFill>
-              </a:rPr>
-              <a:t>ProofOfWork IDs and credits are transferable market assets.</a:t>
-            </a:r>
-          </a:p>
-          <a:p>
-            <a:pPr/>
-            <a:r>
-              <a:rPr lang="en-US" sz="2050">
-                <a:solidFill>
-                  <a:srgbClr val="1f2937"/>
-                </a:solidFill>
-              </a:rPr>
-              <a:t>Current marketplace protocols:</a:t>
+              <a:rPr lang="en-US" sz="1850">
+                <a:solidFill>
+                  <a:srgbClr val="1f2937"/>
+                </a:solidFill>
+              </a:rPr>
+              <a:t>AMO is the Autonomous Money Organization for transferable ProofOfWork IDs and credits.</a:t>
+            </a:r>
+          </a:p>
+          <a:p>
+            <a:pPr/>
+            <a:r>
+              <a:rPr lang="en-US" sz="2050">
+                <a:solidFill>
+                  <a:srgbClr val="1f2937"/>
+                </a:solidFill>
+              </a:rPr>
+              <a:t>Current AMO protocols:</a:t>
             </a:r>
           </a:p>
           <a:p>
@@ -3183,12 +3183,34 @@
           <a:p>
             <a:pPr/>
             <a:r>
+              <a:rPr lang="en-US" sz="2050">
+                <a:solidFill>
+                  <a:srgbClr val="1f2937"/>
+                </a:solidFill>
+              </a:rPr>
+              <a:t>Current governed WORK actions use pwt-sale-v5.</a:t>
+            </a:r>
+          </a:p>
+          <a:p>
+            <a:pPr/>
+            <a:r>
               <a:rPr lang="en-US" sz="1700">
                 <a:solidFill>
                   <a:srgbClr val="1f2937"/>
                 </a:solidFill>
               </a:rPr>
-              <a:t>Current governed WORK list, seal, and buy actions use pwt-sale-v3 with exact atoms and a hash-bound H-1 pricing commitment.</a:t>
+              <a:t>Users choose a $20, $50, or $100 face. Confirmed ProofOfWork order derives and freezes the exact WORK amount and proof price.</a:t>
+            </a:r>
+          </a:p>
+          <a:p>
+            <a:pPr/>
+            <a:r>
+              <a:rPr lang="en-US" sz="2050">
+                <a:solidFill>
+                  <a:srgbClr val="1f2937"/>
+                </a:solidFill>
+              </a:rPr>
+              <a:t>Seals and buys use those frozen terms without later repricing.</a:t>
             </a:r>
           </a:p>
         </p:txBody>

</xml_diff>